<commit_message>
Admin panel - Fix login page if also logined
</commit_message>
<xml_diff>
--- a/.lessons/49 Admin Panel Setup And Mastering/2 Admin Panel - Template mastering/1.pptx
+++ b/.lessons/49 Admin Panel Setup And Mastering/2 Admin Panel - Template mastering/1.pptx
@@ -275,7 +275,7 @@
           <a:p>
             <a:fld id="{3E102D2E-813C-461C-9963-687A650C48C0}" type="datetimeFigureOut">
               <a:rPr lang="en-US" smtClean="0"/>
-              <a:t>7/24/2025</a:t>
+              <a:t>7/25/2025</a:t>
             </a:fld>
             <a:endParaRPr lang="en-US"/>
           </a:p>
@@ -473,7 +473,7 @@
           <a:p>
             <a:fld id="{3E102D2E-813C-461C-9963-687A650C48C0}" type="datetimeFigureOut">
               <a:rPr lang="en-US" smtClean="0"/>
-              <a:t>7/24/2025</a:t>
+              <a:t>7/25/2025</a:t>
             </a:fld>
             <a:endParaRPr lang="en-US"/>
           </a:p>
@@ -681,7 +681,7 @@
           <a:p>
             <a:fld id="{3E102D2E-813C-461C-9963-687A650C48C0}" type="datetimeFigureOut">
               <a:rPr lang="en-US" smtClean="0"/>
-              <a:t>7/24/2025</a:t>
+              <a:t>7/25/2025</a:t>
             </a:fld>
             <a:endParaRPr lang="en-US"/>
           </a:p>
@@ -879,7 +879,7 @@
           <a:p>
             <a:fld id="{3E102D2E-813C-461C-9963-687A650C48C0}" type="datetimeFigureOut">
               <a:rPr lang="en-US" smtClean="0"/>
-              <a:t>7/24/2025</a:t>
+              <a:t>7/25/2025</a:t>
             </a:fld>
             <a:endParaRPr lang="en-US"/>
           </a:p>
@@ -1154,7 +1154,7 @@
           <a:p>
             <a:fld id="{3E102D2E-813C-461C-9963-687A650C48C0}" type="datetimeFigureOut">
               <a:rPr lang="en-US" smtClean="0"/>
-              <a:t>7/24/2025</a:t>
+              <a:t>7/25/2025</a:t>
             </a:fld>
             <a:endParaRPr lang="en-US"/>
           </a:p>
@@ -1419,7 +1419,7 @@
           <a:p>
             <a:fld id="{3E102D2E-813C-461C-9963-687A650C48C0}" type="datetimeFigureOut">
               <a:rPr lang="en-US" smtClean="0"/>
-              <a:t>7/24/2025</a:t>
+              <a:t>7/25/2025</a:t>
             </a:fld>
             <a:endParaRPr lang="en-US"/>
           </a:p>
@@ -1831,7 +1831,7 @@
           <a:p>
             <a:fld id="{3E102D2E-813C-461C-9963-687A650C48C0}" type="datetimeFigureOut">
               <a:rPr lang="en-US" smtClean="0"/>
-              <a:t>7/24/2025</a:t>
+              <a:t>7/25/2025</a:t>
             </a:fld>
             <a:endParaRPr lang="en-US"/>
           </a:p>
@@ -1972,7 +1972,7 @@
           <a:p>
             <a:fld id="{3E102D2E-813C-461C-9963-687A650C48C0}" type="datetimeFigureOut">
               <a:rPr lang="en-US" smtClean="0"/>
-              <a:t>7/24/2025</a:t>
+              <a:t>7/25/2025</a:t>
             </a:fld>
             <a:endParaRPr lang="en-US"/>
           </a:p>
@@ -2085,7 +2085,7 @@
           <a:p>
             <a:fld id="{3E102D2E-813C-461C-9963-687A650C48C0}" type="datetimeFigureOut">
               <a:rPr lang="en-US" smtClean="0"/>
-              <a:t>7/24/2025</a:t>
+              <a:t>7/25/2025</a:t>
             </a:fld>
             <a:endParaRPr lang="en-US"/>
           </a:p>
@@ -2396,7 +2396,7 @@
           <a:p>
             <a:fld id="{3E102D2E-813C-461C-9963-687A650C48C0}" type="datetimeFigureOut">
               <a:rPr lang="en-US" smtClean="0"/>
-              <a:t>7/24/2025</a:t>
+              <a:t>7/25/2025</a:t>
             </a:fld>
             <a:endParaRPr lang="en-US"/>
           </a:p>
@@ -2684,7 +2684,7 @@
           <a:p>
             <a:fld id="{3E102D2E-813C-461C-9963-687A650C48C0}" type="datetimeFigureOut">
               <a:rPr lang="en-US" smtClean="0"/>
-              <a:t>7/24/2025</a:t>
+              <a:t>7/25/2025</a:t>
             </a:fld>
             <a:endParaRPr lang="en-US"/>
           </a:p>
@@ -2925,7 +2925,7 @@
           <a:p>
             <a:fld id="{3E102D2E-813C-461C-9963-687A650C48C0}" type="datetimeFigureOut">
               <a:rPr lang="en-US" smtClean="0"/>
-              <a:t>7/24/2025</a:t>
+              <a:t>7/25/2025</a:t>
             </a:fld>
             <a:endParaRPr lang="en-US"/>
           </a:p>
@@ -4388,10 +4388,10 @@
       </p:sp>
       <p:pic>
         <p:nvPicPr>
-          <p:cNvPr id="6" name="Picture 5">
-            <a:extLst>
-              <a:ext uri="{FF2B5EF4-FFF2-40B4-BE49-F238E27FC236}">
-                <a16:creationId xmlns:a16="http://schemas.microsoft.com/office/drawing/2014/main" id="{93F95B06-A45F-06FC-DB46-6CCDCDFD4F4C}"/>
+          <p:cNvPr id="4" name="Picture 3">
+            <a:extLst>
+              <a:ext uri="{FF2B5EF4-FFF2-40B4-BE49-F238E27FC236}">
+                <a16:creationId xmlns:a16="http://schemas.microsoft.com/office/drawing/2014/main" id="{02E2AD6E-35F3-1373-E56E-26DD4C822F98}"/>
               </a:ext>
             </a:extLst>
           </p:cNvPr>
@@ -4408,26 +4408,12 @@
         </p:blipFill>
         <p:spPr>
           <a:xfrm>
-            <a:off x="0" y="3800465"/>
-            <a:ext cx="12192000" cy="3057535"/>
+            <a:off x="0" y="4183257"/>
+            <a:ext cx="12192000" cy="2674743"/>
           </a:xfrm>
           <a:prstGeom prst="rect">
             <a:avLst/>
           </a:prstGeom>
-          <a:ln w="38100" cap="sq">
-            <a:solidFill>
-              <a:srgbClr val="000000"/>
-            </a:solidFill>
-            <a:prstDash val="solid"/>
-            <a:miter lim="800000"/>
-          </a:ln>
-          <a:effectLst>
-            <a:outerShdw blurRad="50800" dist="38100" dir="2700000" algn="tl" rotWithShape="0">
-              <a:srgbClr val="000000">
-                <a:alpha val="43000"/>
-              </a:srgbClr>
-            </a:outerShdw>
-          </a:effectLst>
         </p:spPr>
       </p:pic>
     </p:spTree>

</xml_diff>